<commit_message>
docs: rename A/B modes to spec validation and migration
</commit_message>
<xml_diff>
--- a/docs/ai-agent-game-dev-guidelines-team-one-page.pptx
+++ b/docs/ai-agent-game-dev-guidelines-team-one-page.pptx
@@ -162,7 +162,7 @@
             <a:pPr algn="ctr"/>
             <a:r>
               <a:rPr lang="ko-KR" sz="1600"/>
-              <a:t>A는 검증용, B는 편입용</a:t>
+              <a:t>A는 스펙 검증용, B는 마이그레이션용</a:t>
             </a:r>
             <a:endParaRPr lang="ko-KR" sz="1600"/>
           </a:p>
@@ -724,7 +724,7 @@
             <a:pPr algn="l"/>
             <a:r>
               <a:rPr lang="ko-KR" sz="1800" b="1"/>
-              <a:t>A: 문서를 수정하면서 검증</a:t>
+              <a:t>A: 스펙 문서를 수정하면서 검증</a:t>
             </a:r>
             <a:endParaRPr lang="ko-KR" sz="1800" b="1"/>
           </a:p>
@@ -814,7 +814,7 @@
             <a:pPr algn="l"/>
             <a:r>
               <a:rPr lang="ko-KR" sz="1800" b="1"/>
-              <a:t>B: 코드와 구조를 수정하며 편입</a:t>
+              <a:t>B: 코드와 구조를 수정하며 마이그레이션</a:t>
             </a:r>
             <a:endParaRPr lang="ko-KR" sz="1800" b="1"/>
           </a:p>

</xml_diff>